<commit_message>
Add the delivery video to the README and keep the presentation deck versioned.
Co-authored-by: Cursor <cursoragent@cursor.com>
</commit_message>
<xml_diff>
--- a/apresentacao/NPS_Preditivo_Fase1.pptx
+++ b/apresentacao/NPS_Preditivo_Fase1.pptx
@@ -136,13 +136,116 @@
 <pc:chgInfo xmlns:a="http://schemas.openxmlformats.org/drawingml/2006/main" xmlns:r="http://schemas.openxmlformats.org/officeDocument/2006/relationships" xmlns:ac="http://schemas.microsoft.com/office/drawing/2013/main/command" xmlns:pc="http://schemas.microsoft.com/office/powerpoint/2013/main/command">
   <pc:docChgLst>
     <pc:chgData name="Cleivin Lauermann" userId="ba4c648b3dd0ed64" providerId="LiveId" clId="{5E27A208-1AA0-46AC-B8C3-8D785BE681F9}"/>
-    <pc:docChg chg="modSld">
-      <pc:chgData name="Cleivin Lauermann" userId="ba4c648b3dd0ed64" providerId="LiveId" clId="{5E27A208-1AA0-46AC-B8C3-8D785BE681F9}" dt="2026-09-01T01:32:32.805" v="10" actId="20577"/>
+    <pc:docChg chg="custSel modSld">
+      <pc:chgData name="Cleivin Lauermann" userId="ba4c648b3dd0ed64" providerId="LiveId" clId="{5E27A208-1AA0-46AC-B8C3-8D785BE681F9}" dt="2026-09-01T02:58:19.465" v="100" actId="20577"/>
       <pc:docMkLst>
         <pc:docMk/>
       </pc:docMkLst>
+      <pc:sldChg chg="delSp modSp mod">
+        <pc:chgData name="Cleivin Lauermann" userId="ba4c648b3dd0ed64" providerId="LiveId" clId="{5E27A208-1AA0-46AC-B8C3-8D785BE681F9}" dt="2026-09-01T02:26:24.386" v="55" actId="20577"/>
+        <pc:sldMkLst>
+          <pc:docMk/>
+          <pc:sldMk cId="0" sldId="256"/>
+        </pc:sldMkLst>
+        <pc:spChg chg="mod">
+          <ac:chgData name="Cleivin Lauermann" userId="ba4c648b3dd0ed64" providerId="LiveId" clId="{5E27A208-1AA0-46AC-B8C3-8D785BE681F9}" dt="2026-09-01T02:25:46.298" v="34" actId="20577"/>
+          <ac:spMkLst>
+            <pc:docMk/>
+            <pc:sldMk cId="0" sldId="256"/>
+            <ac:spMk id="8" creationId="{00000000-0000-0000-0000-000000000000}"/>
+          </ac:spMkLst>
+        </pc:spChg>
+        <pc:spChg chg="del">
+          <ac:chgData name="Cleivin Lauermann" userId="ba4c648b3dd0ed64" providerId="LiveId" clId="{5E27A208-1AA0-46AC-B8C3-8D785BE681F9}" dt="2026-09-01T02:26:06.954" v="48" actId="478"/>
+          <ac:spMkLst>
+            <pc:docMk/>
+            <pc:sldMk cId="0" sldId="256"/>
+            <ac:spMk id="10" creationId="{00000000-0000-0000-0000-000000000000}"/>
+          </ac:spMkLst>
+        </pc:spChg>
+        <pc:spChg chg="del mod">
+          <ac:chgData name="Cleivin Lauermann" userId="ba4c648b3dd0ed64" providerId="LiveId" clId="{5E27A208-1AA0-46AC-B8C3-8D785BE681F9}" dt="2026-09-01T02:26:08.250" v="49" actId="478"/>
+          <ac:spMkLst>
+            <pc:docMk/>
+            <pc:sldMk cId="0" sldId="256"/>
+            <ac:spMk id="11" creationId="{00000000-0000-0000-0000-000000000000}"/>
+          </ac:spMkLst>
+        </pc:spChg>
+        <pc:spChg chg="del">
+          <ac:chgData name="Cleivin Lauermann" userId="ba4c648b3dd0ed64" providerId="LiveId" clId="{5E27A208-1AA0-46AC-B8C3-8D785BE681F9}" dt="2026-09-01T02:26:05.306" v="46" actId="478"/>
+          <ac:spMkLst>
+            <pc:docMk/>
+            <pc:sldMk cId="0" sldId="256"/>
+            <ac:spMk id="12" creationId="{00000000-0000-0000-0000-000000000000}"/>
+          </ac:spMkLst>
+        </pc:spChg>
+        <pc:spChg chg="del">
+          <ac:chgData name="Cleivin Lauermann" userId="ba4c648b3dd0ed64" providerId="LiveId" clId="{5E27A208-1AA0-46AC-B8C3-8D785BE681F9}" dt="2026-09-01T02:26:09.914" v="50" actId="478"/>
+          <ac:spMkLst>
+            <pc:docMk/>
+            <pc:sldMk cId="0" sldId="256"/>
+            <ac:spMk id="13" creationId="{00000000-0000-0000-0000-000000000000}"/>
+          </ac:spMkLst>
+        </pc:spChg>
+        <pc:spChg chg="del">
+          <ac:chgData name="Cleivin Lauermann" userId="ba4c648b3dd0ed64" providerId="LiveId" clId="{5E27A208-1AA0-46AC-B8C3-8D785BE681F9}" dt="2026-09-01T02:26:11.450" v="51" actId="478"/>
+          <ac:spMkLst>
+            <pc:docMk/>
+            <pc:sldMk cId="0" sldId="256"/>
+            <ac:spMk id="14" creationId="{00000000-0000-0000-0000-000000000000}"/>
+          </ac:spMkLst>
+        </pc:spChg>
+        <pc:spChg chg="del">
+          <ac:chgData name="Cleivin Lauermann" userId="ba4c648b3dd0ed64" providerId="LiveId" clId="{5E27A208-1AA0-46AC-B8C3-8D785BE681F9}" dt="2026-09-01T02:26:12.841" v="52" actId="478"/>
+          <ac:spMkLst>
+            <pc:docMk/>
+            <pc:sldMk cId="0" sldId="256"/>
+            <ac:spMk id="15" creationId="{00000000-0000-0000-0000-000000000000}"/>
+          </ac:spMkLst>
+        </pc:spChg>
+        <pc:spChg chg="del">
+          <ac:chgData name="Cleivin Lauermann" userId="ba4c648b3dd0ed64" providerId="LiveId" clId="{5E27A208-1AA0-46AC-B8C3-8D785BE681F9}" dt="2026-09-01T02:24:23.355" v="12" actId="478"/>
+          <ac:spMkLst>
+            <pc:docMk/>
+            <pc:sldMk cId="0" sldId="256"/>
+            <ac:spMk id="16" creationId="{00000000-0000-0000-0000-000000000000}"/>
+          </ac:spMkLst>
+        </pc:spChg>
+        <pc:spChg chg="del">
+          <ac:chgData name="Cleivin Lauermann" userId="ba4c648b3dd0ed64" providerId="LiveId" clId="{5E27A208-1AA0-46AC-B8C3-8D785BE681F9}" dt="2026-09-01T02:24:22.485" v="11" actId="478"/>
+          <ac:spMkLst>
+            <pc:docMk/>
+            <pc:sldMk cId="0" sldId="256"/>
+            <ac:spMk id="17" creationId="{00000000-0000-0000-0000-000000000000}"/>
+          </ac:spMkLst>
+        </pc:spChg>
+        <pc:spChg chg="del mod">
+          <ac:chgData name="Cleivin Lauermann" userId="ba4c648b3dd0ed64" providerId="LiveId" clId="{5E27A208-1AA0-46AC-B8C3-8D785BE681F9}" dt="2026-09-01T02:24:24.763" v="14" actId="478"/>
+          <ac:spMkLst>
+            <pc:docMk/>
+            <pc:sldMk cId="0" sldId="256"/>
+            <ac:spMk id="18" creationId="{00000000-0000-0000-0000-000000000000}"/>
+          </ac:spMkLst>
+        </pc:spChg>
+        <pc:spChg chg="mod">
+          <ac:chgData name="Cleivin Lauermann" userId="ba4c648b3dd0ed64" providerId="LiveId" clId="{5E27A208-1AA0-46AC-B8C3-8D785BE681F9}" dt="2026-09-01T02:24:42.290" v="30" actId="20577"/>
+          <ac:spMkLst>
+            <pc:docMk/>
+            <pc:sldMk cId="0" sldId="256"/>
+            <ac:spMk id="19" creationId="{00000000-0000-0000-0000-000000000000}"/>
+          </ac:spMkLst>
+        </pc:spChg>
+        <pc:spChg chg="mod">
+          <ac:chgData name="Cleivin Lauermann" userId="ba4c648b3dd0ed64" providerId="LiveId" clId="{5E27A208-1AA0-46AC-B8C3-8D785BE681F9}" dt="2026-09-01T02:26:24.386" v="55" actId="20577"/>
+          <ac:spMkLst>
+            <pc:docMk/>
+            <pc:sldMk cId="0" sldId="256"/>
+            <ac:spMk id="20" creationId="{00000000-0000-0000-0000-000000000000}"/>
+          </ac:spMkLst>
+        </pc:spChg>
+      </pc:sldChg>
       <pc:sldChg chg="modSp mod">
-        <pc:chgData name="Cleivin Lauermann" userId="ba4c648b3dd0ed64" providerId="LiveId" clId="{5E27A208-1AA0-46AC-B8C3-8D785BE681F9}" dt="2026-09-01T01:32:32.805" v="10" actId="20577"/>
+        <pc:chgData name="Cleivin Lauermann" userId="ba4c648b3dd0ed64" providerId="LiveId" clId="{5E27A208-1AA0-46AC-B8C3-8D785BE681F9}" dt="2026-09-01T02:44:59.956" v="99" actId="20577"/>
         <pc:sldMkLst>
           <pc:docMk/>
           <pc:sldMk cId="0" sldId="257"/>
@@ -153,6 +256,53 @@
             <pc:docMk/>
             <pc:sldMk cId="0" sldId="257"/>
             <ac:spMk id="11" creationId="{00000000-0000-0000-0000-000000000000}"/>
+          </ac:spMkLst>
+        </pc:spChg>
+        <pc:spChg chg="mod">
+          <ac:chgData name="Cleivin Lauermann" userId="ba4c648b3dd0ed64" providerId="LiveId" clId="{5E27A208-1AA0-46AC-B8C3-8D785BE681F9}" dt="2026-09-01T02:41:32.607" v="94" actId="20577"/>
+          <ac:spMkLst>
+            <pc:docMk/>
+            <pc:sldMk cId="0" sldId="257"/>
+            <ac:spMk id="29" creationId="{00000000-0000-0000-0000-000000000000}"/>
+          </ac:spMkLst>
+        </pc:spChg>
+        <pc:spChg chg="mod">
+          <ac:chgData name="Cleivin Lauermann" userId="ba4c648b3dd0ed64" providerId="LiveId" clId="{5E27A208-1AA0-46AC-B8C3-8D785BE681F9}" dt="2026-09-01T02:44:52.991" v="95" actId="20577"/>
+          <ac:spMkLst>
+            <pc:docMk/>
+            <pc:sldMk cId="0" sldId="257"/>
+            <ac:spMk id="35" creationId="{00000000-0000-0000-0000-000000000000}"/>
+          </ac:spMkLst>
+        </pc:spChg>
+        <pc:spChg chg="mod">
+          <ac:chgData name="Cleivin Lauermann" userId="ba4c648b3dd0ed64" providerId="LiveId" clId="{5E27A208-1AA0-46AC-B8C3-8D785BE681F9}" dt="2026-09-01T02:44:59.956" v="99" actId="20577"/>
+          <ac:spMkLst>
+            <pc:docMk/>
+            <pc:sldMk cId="0" sldId="257"/>
+            <ac:spMk id="39" creationId="{00000000-0000-0000-0000-000000000000}"/>
+          </ac:spMkLst>
+        </pc:spChg>
+        <pc:spChg chg="mod">
+          <ac:chgData name="Cleivin Lauermann" userId="ba4c648b3dd0ed64" providerId="LiveId" clId="{5E27A208-1AA0-46AC-B8C3-8D785BE681F9}" dt="2026-09-01T02:44:55.447" v="96" actId="20577"/>
+          <ac:spMkLst>
+            <pc:docMk/>
+            <pc:sldMk cId="0" sldId="257"/>
+            <ac:spMk id="43" creationId="{00000000-0000-0000-0000-000000000000}"/>
+          </ac:spMkLst>
+        </pc:spChg>
+      </pc:sldChg>
+      <pc:sldChg chg="modSp mod">
+        <pc:chgData name="Cleivin Lauermann" userId="ba4c648b3dd0ed64" providerId="LiveId" clId="{5E27A208-1AA0-46AC-B8C3-8D785BE681F9}" dt="2026-09-01T02:58:19.465" v="100" actId="20577"/>
+        <pc:sldMkLst>
+          <pc:docMk/>
+          <pc:sldMk cId="0" sldId="258"/>
+        </pc:sldMkLst>
+        <pc:spChg chg="mod">
+          <ac:chgData name="Cleivin Lauermann" userId="ba4c648b3dd0ed64" providerId="LiveId" clId="{5E27A208-1AA0-46AC-B8C3-8D785BE681F9}" dt="2026-09-01T02:58:19.465" v="100" actId="20577"/>
+          <ac:spMkLst>
+            <pc:docMk/>
+            <pc:sldMk cId="0" sldId="258"/>
+            <ac:spMk id="20" creationId="{00000000-0000-0000-0000-000000000000}"/>
           </ac:spMkLst>
         </pc:spChg>
       </pc:sldChg>
@@ -3886,13 +4036,49 @@
           <a:p>
             <a:pPr algn="l"/>
             <a:r>
-              <a:rPr sz="3600" b="1" i="0">
+              <a:rPr sz="3600" b="1" i="0" dirty="0">
                 <a:solidFill>
                   <a:srgbClr val="FFFFFF"/>
                 </a:solidFill>
                 <a:latin typeface="Calibri"/>
               </a:rPr>
-              <a:t>NPS preditivo em e-commerce</a:t>
+              <a:t>NPS </a:t>
+            </a:r>
+            <a:r>
+              <a:rPr sz="3600" b="1" i="0" dirty="0" err="1">
+                <a:solidFill>
+                  <a:srgbClr val="FFFFFF"/>
+                </a:solidFill>
+                <a:latin typeface="Calibri"/>
+              </a:rPr>
+              <a:t>preditivo</a:t>
+            </a:r>
+            <a:r>
+              <a:rPr sz="3600" b="1" i="0" dirty="0">
+                <a:solidFill>
+                  <a:srgbClr val="FFFFFF"/>
+                </a:solidFill>
+                <a:latin typeface="Calibri"/>
+              </a:rPr>
+              <a:t> </a:t>
+            </a:r>
+            <a:r>
+              <a:rPr sz="3600" b="1" i="0" dirty="0" err="1">
+                <a:solidFill>
+                  <a:srgbClr val="FFFFFF"/>
+                </a:solidFill>
+                <a:latin typeface="Calibri"/>
+              </a:rPr>
+              <a:t>em</a:t>
+            </a:r>
+            <a:r>
+              <a:rPr sz="3600" b="1" i="0" dirty="0">
+                <a:solidFill>
+                  <a:srgbClr val="FFFFFF"/>
+                </a:solidFill>
+                <a:latin typeface="Calibri"/>
+              </a:rPr>
+              <a:t> e-commerce</a:t>
             </a:r>
           </a:p>
         </p:txBody>
@@ -3999,13 +4185,31 @@
           <a:p>
             <a:pPr algn="l"/>
             <a:r>
-              <a:rPr sz="2400" b="1" i="0">
+              <a:rPr sz="2400" b="1" i="0" dirty="0">
                 <a:solidFill>
                   <a:srgbClr val="E65100"/>
                 </a:solidFill>
                 <a:latin typeface="Calibri"/>
               </a:rPr>
-              <a:t>73,5%</a:t>
+              <a:t>7</a:t>
+            </a:r>
+            <a:r>
+              <a:rPr lang="pt-BR" sz="2400" b="1" i="0" dirty="0">
+                <a:solidFill>
+                  <a:srgbClr val="E65100"/>
+                </a:solidFill>
+                <a:latin typeface="Calibri"/>
+              </a:rPr>
+              <a:t>4</a:t>
+            </a:r>
+            <a:r>
+              <a:rPr sz="2400" b="1" i="0" dirty="0">
+                <a:solidFill>
+                  <a:srgbClr val="E65100"/>
+                </a:solidFill>
+                <a:latin typeface="Calibri"/>
+              </a:rPr>
+              <a:t>%</a:t>
             </a:r>
           </a:p>
         </p:txBody>
@@ -4045,342 +4249,6 @@
       </p:sp>
       <p:sp>
         <p:nvSpPr>
-          <p:cNvPr id="10" name="Rounded Rectangle 9"/>
-          <p:cNvSpPr/>
-          <p:nvPr/>
-        </p:nvSpPr>
-        <p:spPr>
-          <a:xfrm>
-            <a:off x="3429000" y="3794760"/>
-            <a:ext cx="2606040" cy="1280160"/>
-          </a:xfrm>
-          <a:prstGeom prst="roundRect">
-            <a:avLst>
-              <a:gd name="adj" fmla="val 8000"/>
-            </a:avLst>
-          </a:prstGeom>
-          <a:solidFill>
-            <a:srgbClr val="1B263B"/>
-          </a:solidFill>
-          <a:ln>
-            <a:noFill/>
-          </a:ln>
-        </p:spPr>
-        <p:style>
-          <a:lnRef idx="1">
-            <a:schemeClr val="accent1"/>
-          </a:lnRef>
-          <a:fillRef idx="3">
-            <a:schemeClr val="accent1"/>
-          </a:fillRef>
-          <a:effectRef idx="2">
-            <a:schemeClr val="accent1"/>
-          </a:effectRef>
-          <a:fontRef idx="minor">
-            <a:schemeClr val="lt1"/>
-          </a:fontRef>
-        </p:style>
-        <p:txBody>
-          <a:bodyPr rtlCol="0" anchor="ctr"/>
-          <a:lstStyle/>
-          <a:p>
-            <a:pPr algn="ctr"/>
-            <a:endParaRPr/>
-          </a:p>
-        </p:txBody>
-      </p:sp>
-      <p:sp>
-        <p:nvSpPr>
-          <p:cNvPr id="11" name="TextBox 10"/>
-          <p:cNvSpPr txBox="1"/>
-          <p:nvPr/>
-        </p:nvSpPr>
-        <p:spPr>
-          <a:xfrm>
-            <a:off x="3566160" y="3931920"/>
-            <a:ext cx="2331720" cy="502920"/>
-          </a:xfrm>
-          <a:prstGeom prst="rect">
-            <a:avLst/>
-          </a:prstGeom>
-          <a:noFill/>
-        </p:spPr>
-        <p:txBody>
-          <a:bodyPr wrap="square" lIns="36576" tIns="18288" rIns="36576" bIns="18288" anchor="t"/>
-          <a:lstStyle/>
-          <a:p>
-            <a:pPr algn="l"/>
-            <a:r>
-              <a:rPr sz="2400" b="1" i="0">
-                <a:solidFill>
-                  <a:srgbClr val="E65100"/>
-                </a:solidFill>
-                <a:latin typeface="Calibri"/>
-              </a:rPr>
-              <a:t>≥ 3 dias</a:t>
-            </a:r>
-          </a:p>
-        </p:txBody>
-      </p:sp>
-      <p:sp>
-        <p:nvSpPr>
-          <p:cNvPr id="12" name="TextBox 11"/>
-          <p:cNvSpPr txBox="1"/>
-          <p:nvPr/>
-        </p:nvSpPr>
-        <p:spPr>
-          <a:xfrm>
-            <a:off x="3566160" y="4480560"/>
-            <a:ext cx="2331720" cy="411480"/>
-          </a:xfrm>
-          <a:prstGeom prst="rect">
-            <a:avLst/>
-          </a:prstGeom>
-          <a:noFill/>
-        </p:spPr>
-        <p:txBody>
-          <a:bodyPr wrap="square" lIns="36576" tIns="18288" rIns="36576" bIns="18288" anchor="t"/>
-          <a:lstStyle/>
-          <a:p>
-            <a:pPr algn="l"/>
-            <a:r>
-              <a:rPr sz="1300" b="0" i="0">
-                <a:solidFill>
-                  <a:srgbClr val="94A3B8"/>
-                </a:solidFill>
-                <a:latin typeface="Calibri"/>
-              </a:rPr>
-              <a:t>a experiência quebra</a:t>
-            </a:r>
-          </a:p>
-        </p:txBody>
-      </p:sp>
-      <p:sp>
-        <p:nvSpPr>
-          <p:cNvPr id="13" name="Rounded Rectangle 12"/>
-          <p:cNvSpPr/>
-          <p:nvPr/>
-        </p:nvSpPr>
-        <p:spPr>
-          <a:xfrm>
-            <a:off x="6217920" y="3794760"/>
-            <a:ext cx="2606040" cy="1280160"/>
-          </a:xfrm>
-          <a:prstGeom prst="roundRect">
-            <a:avLst>
-              <a:gd name="adj" fmla="val 8000"/>
-            </a:avLst>
-          </a:prstGeom>
-          <a:solidFill>
-            <a:srgbClr val="1B263B"/>
-          </a:solidFill>
-          <a:ln>
-            <a:noFill/>
-          </a:ln>
-        </p:spPr>
-        <p:style>
-          <a:lnRef idx="1">
-            <a:schemeClr val="accent1"/>
-          </a:lnRef>
-          <a:fillRef idx="3">
-            <a:schemeClr val="accent1"/>
-          </a:fillRef>
-          <a:effectRef idx="2">
-            <a:schemeClr val="accent1"/>
-          </a:effectRef>
-          <a:fontRef idx="minor">
-            <a:schemeClr val="lt1"/>
-          </a:fontRef>
-        </p:style>
-        <p:txBody>
-          <a:bodyPr rtlCol="0" anchor="ctr"/>
-          <a:lstStyle/>
-          <a:p>
-            <a:pPr algn="ctr"/>
-            <a:endParaRPr/>
-          </a:p>
-        </p:txBody>
-      </p:sp>
-      <p:sp>
-        <p:nvSpPr>
-          <p:cNvPr id="14" name="TextBox 13"/>
-          <p:cNvSpPr txBox="1"/>
-          <p:nvPr/>
-        </p:nvSpPr>
-        <p:spPr>
-          <a:xfrm>
-            <a:off x="6355080" y="3931920"/>
-            <a:ext cx="2331720" cy="502920"/>
-          </a:xfrm>
-          <a:prstGeom prst="rect">
-            <a:avLst/>
-          </a:prstGeom>
-          <a:noFill/>
-        </p:spPr>
-        <p:txBody>
-          <a:bodyPr wrap="square" lIns="36576" tIns="18288" rIns="36576" bIns="18288" anchor="t"/>
-          <a:lstStyle/>
-          <a:p>
-            <a:pPr algn="l"/>
-            <a:r>
-              <a:rPr sz="2400" b="1" i="0">
-                <a:solidFill>
-                  <a:srgbClr val="E65100"/>
-                </a:solidFill>
-                <a:latin typeface="Calibri"/>
-              </a:rPr>
-              <a:t>−1 pt / dia</a:t>
-            </a:r>
-          </a:p>
-        </p:txBody>
-      </p:sp>
-      <p:sp>
-        <p:nvSpPr>
-          <p:cNvPr id="15" name="TextBox 14"/>
-          <p:cNvSpPr txBox="1"/>
-          <p:nvPr/>
-        </p:nvSpPr>
-        <p:spPr>
-          <a:xfrm>
-            <a:off x="6355080" y="4480560"/>
-            <a:ext cx="2331720" cy="411480"/>
-          </a:xfrm>
-          <a:prstGeom prst="rect">
-            <a:avLst/>
-          </a:prstGeom>
-          <a:noFill/>
-        </p:spPr>
-        <p:txBody>
-          <a:bodyPr wrap="square" lIns="36576" tIns="18288" rIns="36576" bIns="18288" anchor="t"/>
-          <a:lstStyle/>
-          <a:p>
-            <a:pPr algn="l"/>
-            <a:r>
-              <a:rPr sz="1300" b="0" i="0">
-                <a:solidFill>
-                  <a:srgbClr val="94A3B8"/>
-                </a:solidFill>
-                <a:latin typeface="Calibri"/>
-              </a:rPr>
-              <a:t>efeito do atraso</a:t>
-            </a:r>
-          </a:p>
-        </p:txBody>
-      </p:sp>
-      <p:sp>
-        <p:nvSpPr>
-          <p:cNvPr id="16" name="Rounded Rectangle 15"/>
-          <p:cNvSpPr/>
-          <p:nvPr/>
-        </p:nvSpPr>
-        <p:spPr>
-          <a:xfrm>
-            <a:off x="9006839" y="3794760"/>
-            <a:ext cx="2606040" cy="1280160"/>
-          </a:xfrm>
-          <a:prstGeom prst="roundRect">
-            <a:avLst>
-              <a:gd name="adj" fmla="val 8000"/>
-            </a:avLst>
-          </a:prstGeom>
-          <a:solidFill>
-            <a:srgbClr val="1B263B"/>
-          </a:solidFill>
-          <a:ln>
-            <a:noFill/>
-          </a:ln>
-        </p:spPr>
-        <p:style>
-          <a:lnRef idx="1">
-            <a:schemeClr val="accent1"/>
-          </a:lnRef>
-          <a:fillRef idx="3">
-            <a:schemeClr val="accent1"/>
-          </a:fillRef>
-          <a:effectRef idx="2">
-            <a:schemeClr val="accent1"/>
-          </a:effectRef>
-          <a:fontRef idx="minor">
-            <a:schemeClr val="lt1"/>
-          </a:fontRef>
-        </p:style>
-        <p:txBody>
-          <a:bodyPr rtlCol="0" anchor="ctr"/>
-          <a:lstStyle/>
-          <a:p>
-            <a:pPr algn="ctr"/>
-            <a:endParaRPr/>
-          </a:p>
-        </p:txBody>
-      </p:sp>
-      <p:sp>
-        <p:nvSpPr>
-          <p:cNvPr id="17" name="TextBox 16"/>
-          <p:cNvSpPr txBox="1"/>
-          <p:nvPr/>
-        </p:nvSpPr>
-        <p:spPr>
-          <a:xfrm>
-            <a:off x="9143999" y="3931920"/>
-            <a:ext cx="2331720" cy="502920"/>
-          </a:xfrm>
-          <a:prstGeom prst="rect">
-            <a:avLst/>
-          </a:prstGeom>
-          <a:noFill/>
-        </p:spPr>
-        <p:txBody>
-          <a:bodyPr wrap="square" lIns="36576" tIns="18288" rIns="36576" bIns="18288" anchor="t"/>
-          <a:lstStyle/>
-          <a:p>
-            <a:pPr algn="l"/>
-            <a:r>
-              <a:rPr sz="2400" b="1" i="0">
-                <a:solidFill>
-                  <a:srgbClr val="E65100"/>
-                </a:solidFill>
-                <a:latin typeface="Calibri"/>
-              </a:rPr>
-              <a:t>2º dia</a:t>
-            </a:r>
-          </a:p>
-        </p:txBody>
-      </p:sp>
-      <p:sp>
-        <p:nvSpPr>
-          <p:cNvPr id="18" name="TextBox 17"/>
-          <p:cNvSpPr txBox="1"/>
-          <p:nvPr/>
-        </p:nvSpPr>
-        <p:spPr>
-          <a:xfrm>
-            <a:off x="9143999" y="4480560"/>
-            <a:ext cx="2331720" cy="411480"/>
-          </a:xfrm>
-          <a:prstGeom prst="rect">
-            <a:avLst/>
-          </a:prstGeom>
-          <a:noFill/>
-        </p:spPr>
-        <p:txBody>
-          <a:bodyPr wrap="square" lIns="36576" tIns="18288" rIns="36576" bIns="18288" anchor="t"/>
-          <a:lstStyle/>
-          <a:p>
-            <a:pPr algn="l"/>
-            <a:r>
-              <a:rPr sz="1300" b="0" i="0">
-                <a:solidFill>
-                  <a:srgbClr val="94A3B8"/>
-                </a:solidFill>
-                <a:latin typeface="Calibri"/>
-              </a:rPr>
-              <a:t>hora de agir</a:t>
-            </a:r>
-          </a:p>
-        </p:txBody>
-      </p:sp>
-      <p:sp>
-        <p:nvSpPr>
           <p:cNvPr id="19" name="TextBox 18"/>
           <p:cNvSpPr txBox="1"/>
           <p:nvPr/>
@@ -4401,14 +4269,56 @@
           <a:p>
             <a:pPr algn="l"/>
             <a:r>
-              <a:rPr sz="1600" b="1" i="0">
+              <a:rPr sz="1600" b="1" i="0" dirty="0" err="1">
                 <a:solidFill>
                   <a:srgbClr val="E65100"/>
                 </a:solidFill>
                 <a:latin typeface="Calibri"/>
               </a:rPr>
-              <a:t>Problema  →  prova  →  números  →  solução  →  confirmação</a:t>
-            </a:r>
+              <a:t>Problema</a:t>
+            </a:r>
+            <a:r>
+              <a:rPr sz="1600" b="1" i="0" dirty="0">
+                <a:solidFill>
+                  <a:srgbClr val="E65100"/>
+                </a:solidFill>
+                <a:latin typeface="Calibri"/>
+              </a:rPr>
+              <a:t>  →  </a:t>
+            </a:r>
+            <a:r>
+              <a:rPr lang="pt-BR" sz="1600" b="1" dirty="0">
+                <a:solidFill>
+                  <a:srgbClr val="E65100"/>
+                </a:solidFill>
+                <a:latin typeface="Calibri"/>
+              </a:rPr>
+              <a:t>Análise</a:t>
+            </a:r>
+            <a:r>
+              <a:rPr sz="1600" b="1" i="0" dirty="0">
+                <a:solidFill>
+                  <a:srgbClr val="E65100"/>
+                </a:solidFill>
+                <a:latin typeface="Calibri"/>
+              </a:rPr>
+              <a:t>  →  </a:t>
+            </a:r>
+            <a:r>
+              <a:rPr sz="1600" b="1" i="0" dirty="0" err="1">
+                <a:solidFill>
+                  <a:srgbClr val="E65100"/>
+                </a:solidFill>
+                <a:latin typeface="Calibri"/>
+              </a:rPr>
+              <a:t>solução</a:t>
+            </a:r>
+            <a:endParaRPr sz="1600" b="1" i="0" dirty="0">
+              <a:solidFill>
+                <a:srgbClr val="E65100"/>
+              </a:solidFill>
+              <a:latin typeface="Calibri"/>
+            </a:endParaRPr>
           </a:p>
         </p:txBody>
       </p:sp>
@@ -4434,14 +4344,74 @@
           <a:p>
             <a:pPr algn="l"/>
             <a:r>
-              <a:rPr sz="1200" b="0" i="0">
+              <a:rPr sz="1200" b="0" i="0" dirty="0">
                 <a:solidFill>
                   <a:srgbClr val="64748B"/>
                 </a:solidFill>
                 <a:latin typeface="Calibri"/>
               </a:rPr>
-              <a:t>2.356 pedidos filtrados  ·  target: nps_score  ·  vídeo de 5 minutos</a:t>
-            </a:r>
+              <a:t>2.356 </a:t>
+            </a:r>
+            <a:r>
+              <a:rPr sz="1200" b="0" i="0" dirty="0" err="1">
+                <a:solidFill>
+                  <a:srgbClr val="64748B"/>
+                </a:solidFill>
+                <a:latin typeface="Calibri"/>
+              </a:rPr>
+              <a:t>pedidos</a:t>
+            </a:r>
+            <a:r>
+              <a:rPr sz="1200" b="0" i="0" dirty="0">
+                <a:solidFill>
+                  <a:srgbClr val="64748B"/>
+                </a:solidFill>
+                <a:latin typeface="Calibri"/>
+              </a:rPr>
+              <a:t> </a:t>
+            </a:r>
+            <a:r>
+              <a:rPr sz="1200" b="0" i="0" dirty="0" err="1">
+                <a:solidFill>
+                  <a:srgbClr val="64748B"/>
+                </a:solidFill>
+                <a:latin typeface="Calibri"/>
+              </a:rPr>
+              <a:t>filtrados</a:t>
+            </a:r>
+            <a:r>
+              <a:rPr sz="1200" b="0" i="0" dirty="0">
+                <a:solidFill>
+                  <a:srgbClr val="64748B"/>
+                </a:solidFill>
+                <a:latin typeface="Calibri"/>
+              </a:rPr>
+              <a:t>  ·  target: </a:t>
+            </a:r>
+            <a:r>
+              <a:rPr sz="1200" b="0" i="0" dirty="0" err="1">
+                <a:solidFill>
+                  <a:srgbClr val="64748B"/>
+                </a:solidFill>
+                <a:latin typeface="Calibri"/>
+              </a:rPr>
+              <a:t>nps_scor</a:t>
+            </a:r>
+            <a:r>
+              <a:rPr lang="pt-BR" sz="1200" b="0" i="0" dirty="0">
+                <a:solidFill>
+                  <a:srgbClr val="64748B"/>
+                </a:solidFill>
+                <a:latin typeface="Calibri"/>
+              </a:rPr>
+              <a:t>e</a:t>
+            </a:r>
+            <a:endParaRPr sz="1200" b="0" i="0" dirty="0">
+              <a:solidFill>
+                <a:srgbClr val="64748B"/>
+              </a:solidFill>
+              <a:latin typeface="Calibri"/>
+            </a:endParaRPr>
           </a:p>
         </p:txBody>
       </p:sp>
@@ -5603,15 +5573,47 @@
           <a:p>
             <a:pPr algn="l"/>
             <a:r>
-              <a:rPr sz="1300" b="0" i="0">
+              <a:rPr sz="1300" b="0" i="0" dirty="0">
                 <a:solidFill>
                   <a:srgbClr val="5B677A"/>
                 </a:solidFill>
                 <a:latin typeface="Calibri"/>
               </a:rPr>
-              <a:t>Menos recompra, boca a boca
-negativo e risco de churn.</a:t>
-            </a:r>
+              <a:t>Menos </a:t>
+            </a:r>
+            <a:r>
+              <a:rPr sz="1300" b="0" i="0" dirty="0" err="1">
+                <a:solidFill>
+                  <a:srgbClr val="5B677A"/>
+                </a:solidFill>
+                <a:latin typeface="Calibri"/>
+              </a:rPr>
+              <a:t>recompra</a:t>
+            </a:r>
+            <a:r>
+              <a:rPr sz="1300" b="0" i="0" dirty="0">
+                <a:solidFill>
+                  <a:srgbClr val="5B677A"/>
+                </a:solidFill>
+                <a:latin typeface="Calibri"/>
+              </a:rPr>
+              <a:t>, </a:t>
+            </a:r>
+            <a:r>
+              <a:rPr lang="pt-BR" sz="1300" b="0" i="0" dirty="0">
+                <a:solidFill>
+                  <a:srgbClr val="5B677A"/>
+                </a:solidFill>
+                <a:latin typeface="Calibri"/>
+              </a:rPr>
+              <a:t>menos clientes novos e má reputação.</a:t>
+            </a:r>
+            <a:endParaRPr sz="1300" b="0" i="0" dirty="0">
+              <a:solidFill>
+                <a:srgbClr val="5B677A"/>
+              </a:solidFill>
+              <a:latin typeface="Calibri"/>
+            </a:endParaRPr>
           </a:p>
         </p:txBody>
       </p:sp>
@@ -5828,13 +5830,31 @@
           <a:p>
             <a:pPr algn="l"/>
             <a:r>
-              <a:rPr sz="2800" b="1" i="0">
+              <a:rPr sz="2800" b="1" i="0" dirty="0">
                 <a:solidFill>
                   <a:srgbClr val="B71C1C"/>
                 </a:solidFill>
                 <a:latin typeface="Calibri"/>
               </a:rPr>
-              <a:t>73,5%</a:t>
+              <a:t>7</a:t>
+            </a:r>
+            <a:r>
+              <a:rPr lang="pt-BR" sz="2800" b="1" i="0" dirty="0">
+                <a:solidFill>
+                  <a:srgbClr val="B71C1C"/>
+                </a:solidFill>
+                <a:latin typeface="Calibri"/>
+              </a:rPr>
+              <a:t>4</a:t>
+            </a:r>
+            <a:r>
+              <a:rPr sz="2800" b="1" i="0" dirty="0">
+                <a:solidFill>
+                  <a:srgbClr val="B71C1C"/>
+                </a:solidFill>
+                <a:latin typeface="Calibri"/>
+              </a:rPr>
+              <a:t>%</a:t>
             </a:r>
           </a:p>
         </p:txBody>
@@ -5973,14 +5993,29 @@
           <a:p>
             <a:pPr algn="l"/>
             <a:r>
-              <a:rPr sz="2800" b="1" i="0">
+              <a:rPr sz="2800" b="1" i="0" dirty="0">
                 <a:solidFill>
                   <a:srgbClr val="B71C1C"/>
                 </a:solidFill>
                 <a:latin typeface="Calibri"/>
               </a:rPr>
-              <a:t>−65,6</a:t>
-            </a:r>
+              <a:t>−6</a:t>
+            </a:r>
+            <a:r>
+              <a:rPr lang="pt-BR" sz="2800" b="1" i="0" dirty="0">
+                <a:solidFill>
+                  <a:srgbClr val="B71C1C"/>
+                </a:solidFill>
+                <a:latin typeface="Calibri"/>
+              </a:rPr>
+              <a:t>6</a:t>
+            </a:r>
+            <a:endParaRPr sz="2800" b="1" i="0" dirty="0">
+              <a:solidFill>
+                <a:srgbClr val="B71C1C"/>
+              </a:solidFill>
+              <a:latin typeface="Calibri"/>
+            </a:endParaRPr>
           </a:p>
         </p:txBody>
       </p:sp>
@@ -6118,13 +6153,22 @@
           <a:p>
             <a:pPr algn="l"/>
             <a:r>
-              <a:rPr sz="2800" b="1" i="0">
+              <a:rPr lang="pt-BR" sz="2800" b="1" i="0" dirty="0">
                 <a:solidFill>
                   <a:srgbClr val="0F766E"/>
                 </a:solidFill>
                 <a:latin typeface="Calibri"/>
               </a:rPr>
-              <a:t>7,9%</a:t>
+              <a:t>8</a:t>
+            </a:r>
+            <a:r>
+              <a:rPr sz="2800" b="1" i="0" dirty="0">
+                <a:solidFill>
+                  <a:srgbClr val="0F766E"/>
+                </a:solidFill>
+                <a:latin typeface="Calibri"/>
+              </a:rPr>
+              <a:t>%</a:t>
             </a:r>
           </a:p>
         </p:txBody>
@@ -6980,13 +7024,67 @@
               </a:spcAft>
             </a:pPr>
             <a:r>
-              <a:rPr sz="1400" b="0" i="0">
+              <a:rPr sz="1400" b="0" i="0" dirty="0">
                 <a:solidFill>
                   <a:srgbClr val="0F172A"/>
                 </a:solidFill>
                 <a:latin typeface="Calibri"/>
               </a:rPr>
-              <a:t>0 a 6 — detrator (não recomendaria)</a:t>
+              <a:t>0 a 6 — </a:t>
+            </a:r>
+            <a:r>
+              <a:rPr sz="1400" b="0" i="0" dirty="0" err="1">
+                <a:solidFill>
+                  <a:srgbClr val="0F172A"/>
+                </a:solidFill>
+                <a:latin typeface="Calibri"/>
+              </a:rPr>
+              <a:t>detrator</a:t>
+            </a:r>
+            <a:r>
+              <a:rPr sz="1400" b="0" i="0" dirty="0">
+                <a:solidFill>
+                  <a:srgbClr val="0F172A"/>
+                </a:solidFill>
+                <a:latin typeface="Calibri"/>
+              </a:rPr>
+              <a:t> (</a:t>
+            </a:r>
+            <a:r>
+              <a:rPr sz="1400" b="0" i="0" dirty="0" err="1">
+                <a:solidFill>
+                  <a:srgbClr val="0F172A"/>
+                </a:solidFill>
+                <a:latin typeface="Calibri"/>
+              </a:rPr>
+              <a:t>não</a:t>
+            </a:r>
+            <a:r>
+              <a:rPr sz="1400" b="0" i="0" dirty="0">
+                <a:solidFill>
+                  <a:srgbClr val="0F172A"/>
+                </a:solidFill>
+                <a:latin typeface="Calibri"/>
+              </a:rPr>
+              <a:t> </a:t>
+            </a:r>
+            <a:r>
+              <a:rPr sz="1400" b="0" i="0" dirty="0" err="1">
+                <a:solidFill>
+                  <a:srgbClr val="0F172A"/>
+                </a:solidFill>
+                <a:latin typeface="Calibri"/>
+              </a:rPr>
+              <a:t>recomendaria</a:t>
+            </a:r>
+            <a:r>
+              <a:rPr sz="1400" b="0" i="0" dirty="0">
+                <a:solidFill>
+                  <a:srgbClr val="0F172A"/>
+                </a:solidFill>
+                <a:latin typeface="Calibri"/>
+              </a:rPr>
+              <a:t>)</a:t>
             </a:r>
           </a:p>
           <a:p>
@@ -6996,14 +7094,29 @@
               </a:spcAft>
             </a:pPr>
             <a:r>
-              <a:rPr sz="1400" b="0" i="0">
+              <a:rPr sz="1400" b="0" i="0" dirty="0">
                 <a:solidFill>
                   <a:srgbClr val="0F172A"/>
                 </a:solidFill>
                 <a:latin typeface="Calibri"/>
               </a:rPr>
-              <a:t>7 e 8 — neutro</a:t>
-            </a:r>
+              <a:t>7 e 8 — </a:t>
+            </a:r>
+            <a:r>
+              <a:rPr sz="1400" b="0" i="0" dirty="0" err="1">
+                <a:solidFill>
+                  <a:srgbClr val="0F172A"/>
+                </a:solidFill>
+                <a:latin typeface="Calibri"/>
+              </a:rPr>
+              <a:t>neutro</a:t>
+            </a:r>
+            <a:endParaRPr sz="1400" b="0" i="0" dirty="0">
+              <a:solidFill>
+                <a:srgbClr val="0F172A"/>
+              </a:solidFill>
+              <a:latin typeface="Calibri"/>
+            </a:endParaRPr>
           </a:p>
           <a:p>
             <a:pPr algn="l">
@@ -7012,45 +7125,13 @@
               </a:spcAft>
             </a:pPr>
             <a:r>
-              <a:rPr sz="1400" b="0" i="0">
+              <a:rPr sz="1400" b="0" i="0" dirty="0">
                 <a:solidFill>
                   <a:srgbClr val="0F172A"/>
                 </a:solidFill>
                 <a:latin typeface="Calibri"/>
               </a:rPr>
               <a:t>9 e 10 — promotor</a:t>
-            </a:r>
-          </a:p>
-          <a:p>
-            <a:pPr algn="l">
-              <a:spcAft>
-                <a:spcPts val="800"/>
-              </a:spcAft>
-            </a:pPr>
-            <a:r>
-              <a:rPr sz="1400" b="0" i="0">
-                <a:solidFill>
-                  <a:srgbClr val="0F172A"/>
-                </a:solidFill>
-                <a:latin typeface="Calibri"/>
-              </a:rPr>
-              <a:t>Fora da previsão: recompra em 30 dias (é depois)</a:t>
-            </a:r>
-          </a:p>
-          <a:p>
-            <a:pPr algn="l">
-              <a:spcAft>
-                <a:spcPts val="400"/>
-              </a:spcAft>
-            </a:pPr>
-            <a:r>
-              <a:rPr sz="1400" b="0" i="0">
-                <a:solidFill>
-                  <a:srgbClr val="5B677A"/>
-                </a:solidFill>
-                <a:latin typeface="Calibri"/>
-              </a:rPr>
-              <a:t>Fora da previsão: nota de atendimento (só existe depois do SAC)</a:t>
             </a:r>
           </a:p>
         </p:txBody>

</xml_diff>